<commit_message>
chore(presentation): attribute the deck to Head of DevOps
The deck was signed "Head of DevOps & Analytics" on the cover, in every footer
and in the closing sign-off. Shorten it to "Head of DevOps" - the role the deck
is actually presented in - across all 11 slides that carry it.

- Cover: presenter line.
- Footers on slides 2-11.
- Slide 11 sign-off block.
- No other content change: 12 slides, same titles, figures and notes.

Also stop the scratch cross-check script showing up as untracked:

- .gitignore: analytics/crosscheck_source.py, plus .gitignore itself, both kept
  locally only. `analytics/_probe.py` is deliberately left visible for now.

The .pptx diff is large because PowerPoint rewrites the package on save; the
only textual change is the presenter name.

Co-authored-by: Copilot <223556219+Copilot@users.noreply.github.com>
</commit_message>
<xml_diff>
--- a/presentation/EXECUTIVE_PRESENTATION.pptx
+++ b/presentation/EXECUTIVE_PRESENTATION.pptx
@@ -5145,7 +5145,7 @@
         <p:spPr>
           <a:xfrm>
             <a:off x="804672" y="6492240"/>
-            <a:ext cx="5486400" cy="182880"/>
+            <a:ext cx="5486400" cy="123111"/>
           </a:xfrm>
           <a:prstGeom prst="rect">
             <a:avLst/>
@@ -5170,14 +5170,20 @@
               </a:spcAft>
             </a:pPr>
             <a:r>
-              <a:rPr sz="800" b="1" i="0">
+              <a:rPr lang="en-IN" sz="800" b="1" i="0" dirty="0">
                 <a:solidFill>
                   <a:srgbClr val="A9B9D0"/>
                 </a:solidFill>
                 <a:latin typeface="Segoe UI Semibold"/>
               </a:rPr>
-              <a:t>Head of DevOps &amp; Analytics</a:t>
-            </a:r>
+              <a:t>Head of DevOps</a:t>
+            </a:r>
+            <a:endParaRPr sz="800" b="1" i="0" dirty="0">
+              <a:solidFill>
+                <a:srgbClr val="A9B9D0"/>
+              </a:solidFill>
+              <a:latin typeface="Segoe UI Semibold"/>
+            </a:endParaRPr>
           </a:p>
         </p:txBody>
       </p:sp>
@@ -7976,7 +7982,7 @@
         <p:spPr>
           <a:xfrm>
             <a:off x="566928" y="6492240"/>
-            <a:ext cx="4023360" cy="182880"/>
+            <a:ext cx="4023360" cy="115416"/>
           </a:xfrm>
           <a:prstGeom prst="rect">
             <a:avLst/>
@@ -8001,14 +8007,38 @@
               </a:spcAft>
             </a:pPr>
             <a:r>
-              <a:rPr sz="750" b="0" i="0">
+              <a:rPr sz="750" b="0" i="0" dirty="0" err="1">
                 <a:solidFill>
                   <a:srgbClr val="7386A0"/>
                 </a:solidFill>
                 <a:latin typeface="Segoe UI"/>
               </a:rPr>
-              <a:t>Cyncly  ·  Head of DevOps &amp; Analytics</a:t>
-            </a:r>
+              <a:t>Cyncly</a:t>
+            </a:r>
+            <a:r>
+              <a:rPr sz="750" b="0" i="0" dirty="0">
+                <a:solidFill>
+                  <a:srgbClr val="7386A0"/>
+                </a:solidFill>
+                <a:latin typeface="Segoe UI"/>
+              </a:rPr>
+              <a:t>  ·  </a:t>
+            </a:r>
+            <a:r>
+              <a:rPr lang="en-IN" sz="750" b="0" i="0" dirty="0">
+                <a:solidFill>
+                  <a:srgbClr val="7386A0"/>
+                </a:solidFill>
+                <a:latin typeface="Segoe UI"/>
+              </a:rPr>
+              <a:t>Head of DevOps</a:t>
+            </a:r>
+            <a:endParaRPr sz="750" b="0" i="0" dirty="0">
+              <a:solidFill>
+                <a:srgbClr val="7386A0"/>
+              </a:solidFill>
+              <a:latin typeface="Segoe UI"/>
+            </a:endParaRPr>
           </a:p>
         </p:txBody>
       </p:sp>
@@ -11074,7 +11104,7 @@
         <p:spPr>
           <a:xfrm>
             <a:off x="9692640" y="5577840"/>
-            <a:ext cx="1737360" cy="457200"/>
+            <a:ext cx="1737360" cy="259623"/>
           </a:xfrm>
           <a:prstGeom prst="rect">
             <a:avLst/>
@@ -11099,7 +11129,7 @@
               </a:spcAft>
             </a:pPr>
             <a:r>
-              <a:rPr sz="710" b="0" i="0">
+              <a:rPr sz="710" b="0" i="0" dirty="0">
                 <a:solidFill>
                   <a:srgbClr val="A9B9D0"/>
                 </a:solidFill>
@@ -11121,29 +11151,7 @@
               </a:spcAft>
             </a:pPr>
             <a:r>
-              <a:rPr sz="710" b="0" i="0">
-                <a:solidFill>
-                  <a:srgbClr val="A9B9D0"/>
-                </a:solidFill>
-                <a:latin typeface="Segoe UI"/>
-              </a:rPr>
-              <a:t>&amp; Analytics</a:t>
-            </a:r>
-          </a:p>
-          <a:p>
-            <a:pPr algn="r">
-              <a:lnSpc>
-                <a:spcPct val="125000"/>
-              </a:lnSpc>
-              <a:spcBef>
-                <a:spcPts val="0"/>
-              </a:spcBef>
-              <a:spcAft>
-                <a:spcPts val="0"/>
-              </a:spcAft>
-            </a:pPr>
-            <a:r>
-              <a:rPr sz="710" b="0" i="0">
+              <a:rPr sz="710" b="0" i="0" dirty="0">
                 <a:solidFill>
                   <a:srgbClr val="A9B9D0"/>
                 </a:solidFill>
@@ -11210,7 +11218,7 @@
         <p:spPr>
           <a:xfrm>
             <a:off x="566928" y="6492240"/>
-            <a:ext cx="4023360" cy="182880"/>
+            <a:ext cx="4023360" cy="115416"/>
           </a:xfrm>
           <a:prstGeom prst="rect">
             <a:avLst/>
@@ -11235,14 +11243,38 @@
               </a:spcAft>
             </a:pPr>
             <a:r>
-              <a:rPr sz="750" b="0" i="0">
+              <a:rPr sz="750" b="0" i="0" dirty="0" err="1">
                 <a:solidFill>
                   <a:srgbClr val="7386A0"/>
                 </a:solidFill>
                 <a:latin typeface="Segoe UI"/>
               </a:rPr>
-              <a:t>Cyncly  ·  Head of DevOps &amp; Analytics</a:t>
-            </a:r>
+              <a:t>Cyncly</a:t>
+            </a:r>
+            <a:r>
+              <a:rPr sz="750" b="0" i="0" dirty="0">
+                <a:solidFill>
+                  <a:srgbClr val="7386A0"/>
+                </a:solidFill>
+                <a:latin typeface="Segoe UI"/>
+              </a:rPr>
+              <a:t>  ·  </a:t>
+            </a:r>
+            <a:r>
+              <a:rPr lang="en-IN" sz="750" b="0" i="0" dirty="0">
+                <a:solidFill>
+                  <a:srgbClr val="7386A0"/>
+                </a:solidFill>
+                <a:latin typeface="Segoe UI"/>
+              </a:rPr>
+              <a:t>Head of DevOps</a:t>
+            </a:r>
+            <a:endParaRPr sz="750" b="0" i="0" dirty="0">
+              <a:solidFill>
+                <a:srgbClr val="7386A0"/>
+              </a:solidFill>
+              <a:latin typeface="Segoe UI"/>
+            </a:endParaRPr>
           </a:p>
         </p:txBody>
       </p:sp>
@@ -14685,7 +14717,7 @@
         <p:spPr>
           <a:xfrm>
             <a:off x="566928" y="6492240"/>
-            <a:ext cx="4023360" cy="182880"/>
+            <a:ext cx="4023360" cy="115416"/>
           </a:xfrm>
           <a:prstGeom prst="rect">
             <a:avLst/>
@@ -14710,14 +14742,38 @@
               </a:spcAft>
             </a:pPr>
             <a:r>
-              <a:rPr sz="750" b="0" i="0">
+              <a:rPr sz="750" b="0" i="0" dirty="0" err="1">
                 <a:solidFill>
                   <a:srgbClr val="7386A0"/>
                 </a:solidFill>
                 <a:latin typeface="Segoe UI"/>
               </a:rPr>
-              <a:t>Cyncly  ·  Head of DevOps &amp; Analytics</a:t>
-            </a:r>
+              <a:t>Cyncly</a:t>
+            </a:r>
+            <a:r>
+              <a:rPr sz="750" b="0" i="0" dirty="0">
+                <a:solidFill>
+                  <a:srgbClr val="7386A0"/>
+                </a:solidFill>
+                <a:latin typeface="Segoe UI"/>
+              </a:rPr>
+              <a:t>  ·  </a:t>
+            </a:r>
+            <a:r>
+              <a:rPr lang="en-IN" sz="750" b="0" i="0" dirty="0">
+                <a:solidFill>
+                  <a:srgbClr val="7386A0"/>
+                </a:solidFill>
+                <a:latin typeface="Segoe UI"/>
+              </a:rPr>
+              <a:t>Head of DevOps</a:t>
+            </a:r>
+            <a:endParaRPr sz="750" b="0" i="0" dirty="0">
+              <a:solidFill>
+                <a:srgbClr val="7386A0"/>
+              </a:solidFill>
+              <a:latin typeface="Segoe UI"/>
+            </a:endParaRPr>
           </a:p>
         </p:txBody>
       </p:sp>
@@ -18228,7 +18284,7 @@
         <p:spPr>
           <a:xfrm>
             <a:off x="566928" y="6492240"/>
-            <a:ext cx="4023360" cy="182880"/>
+            <a:ext cx="4023360" cy="115416"/>
           </a:xfrm>
           <a:prstGeom prst="rect">
             <a:avLst/>
@@ -18253,14 +18309,38 @@
               </a:spcAft>
             </a:pPr>
             <a:r>
-              <a:rPr sz="750" b="0" i="0">
+              <a:rPr sz="750" b="0" i="0" dirty="0" err="1">
                 <a:solidFill>
                   <a:srgbClr val="7386A0"/>
                 </a:solidFill>
                 <a:latin typeface="Segoe UI"/>
               </a:rPr>
-              <a:t>Cyncly  ·  Head of DevOps &amp; Analytics</a:t>
-            </a:r>
+              <a:t>Cyncly</a:t>
+            </a:r>
+            <a:r>
+              <a:rPr sz="750" b="0" i="0" dirty="0">
+                <a:solidFill>
+                  <a:srgbClr val="7386A0"/>
+                </a:solidFill>
+                <a:latin typeface="Segoe UI"/>
+              </a:rPr>
+              <a:t>  ·  </a:t>
+            </a:r>
+            <a:r>
+              <a:rPr lang="en-IN" sz="750" b="0" i="0" dirty="0">
+                <a:solidFill>
+                  <a:srgbClr val="7386A0"/>
+                </a:solidFill>
+                <a:latin typeface="Segoe UI"/>
+              </a:rPr>
+              <a:t>Head of DevOps</a:t>
+            </a:r>
+            <a:endParaRPr sz="750" b="0" i="0" dirty="0">
+              <a:solidFill>
+                <a:srgbClr val="7386A0"/>
+              </a:solidFill>
+              <a:latin typeface="Segoe UI"/>
+            </a:endParaRPr>
           </a:p>
         </p:txBody>
       </p:sp>
@@ -22350,7 +22430,7 @@
         <p:spPr>
           <a:xfrm>
             <a:off x="566928" y="6492240"/>
-            <a:ext cx="4023360" cy="182880"/>
+            <a:ext cx="4023360" cy="115416"/>
           </a:xfrm>
           <a:prstGeom prst="rect">
             <a:avLst/>
@@ -22375,14 +22455,38 @@
               </a:spcAft>
             </a:pPr>
             <a:r>
-              <a:rPr sz="750" b="0" i="0">
+              <a:rPr sz="750" b="0" i="0" dirty="0" err="1">
                 <a:solidFill>
                   <a:srgbClr val="7386A0"/>
                 </a:solidFill>
                 <a:latin typeface="Segoe UI"/>
               </a:rPr>
-              <a:t>Cyncly  ·  Head of DevOps &amp; Analytics</a:t>
-            </a:r>
+              <a:t>Cyncly</a:t>
+            </a:r>
+            <a:r>
+              <a:rPr sz="750" b="0" i="0" dirty="0">
+                <a:solidFill>
+                  <a:srgbClr val="7386A0"/>
+                </a:solidFill>
+                <a:latin typeface="Segoe UI"/>
+              </a:rPr>
+              <a:t>  ·  </a:t>
+            </a:r>
+            <a:r>
+              <a:rPr lang="en-IN" sz="750" b="0" i="0" dirty="0">
+                <a:solidFill>
+                  <a:srgbClr val="7386A0"/>
+                </a:solidFill>
+                <a:latin typeface="Segoe UI"/>
+              </a:rPr>
+              <a:t>Head of DevOps</a:t>
+            </a:r>
+            <a:endParaRPr sz="750" b="0" i="0" dirty="0">
+              <a:solidFill>
+                <a:srgbClr val="7386A0"/>
+              </a:solidFill>
+              <a:latin typeface="Segoe UI"/>
+            </a:endParaRPr>
           </a:p>
         </p:txBody>
       </p:sp>
@@ -24954,7 +25058,7 @@
         <p:spPr>
           <a:xfrm>
             <a:off x="566928" y="6492240"/>
-            <a:ext cx="4023360" cy="182880"/>
+            <a:ext cx="4023360" cy="115416"/>
           </a:xfrm>
           <a:prstGeom prst="rect">
             <a:avLst/>
@@ -24979,14 +25083,38 @@
               </a:spcAft>
             </a:pPr>
             <a:r>
-              <a:rPr sz="750" b="0" i="0">
+              <a:rPr sz="750" b="0" i="0" dirty="0" err="1">
                 <a:solidFill>
                   <a:srgbClr val="7386A0"/>
                 </a:solidFill>
                 <a:latin typeface="Segoe UI"/>
               </a:rPr>
-              <a:t>Cyncly  ·  Head of DevOps &amp; Analytics</a:t>
-            </a:r>
+              <a:t>Cyncly</a:t>
+            </a:r>
+            <a:r>
+              <a:rPr sz="750" b="0" i="0" dirty="0">
+                <a:solidFill>
+                  <a:srgbClr val="7386A0"/>
+                </a:solidFill>
+                <a:latin typeface="Segoe UI"/>
+              </a:rPr>
+              <a:t>  ·  </a:t>
+            </a:r>
+            <a:r>
+              <a:rPr lang="en-IN" sz="750" b="0" i="0" dirty="0">
+                <a:solidFill>
+                  <a:srgbClr val="7386A0"/>
+                </a:solidFill>
+                <a:latin typeface="Segoe UI"/>
+              </a:rPr>
+              <a:t>Head of DevOps</a:t>
+            </a:r>
+            <a:endParaRPr sz="750" b="0" i="0" dirty="0">
+              <a:solidFill>
+                <a:srgbClr val="7386A0"/>
+              </a:solidFill>
+              <a:latin typeface="Segoe UI"/>
+            </a:endParaRPr>
           </a:p>
         </p:txBody>
       </p:sp>
@@ -27472,7 +27600,7 @@
         <p:spPr>
           <a:xfrm>
             <a:off x="566928" y="6492240"/>
-            <a:ext cx="4023360" cy="182880"/>
+            <a:ext cx="4023360" cy="115416"/>
           </a:xfrm>
           <a:prstGeom prst="rect">
             <a:avLst/>
@@ -27497,14 +27625,38 @@
               </a:spcAft>
             </a:pPr>
             <a:r>
-              <a:rPr sz="750" b="0" i="0">
+              <a:rPr sz="750" b="0" i="0" dirty="0" err="1">
                 <a:solidFill>
                   <a:srgbClr val="7386A0"/>
                 </a:solidFill>
                 <a:latin typeface="Segoe UI"/>
               </a:rPr>
-              <a:t>Cyncly  ·  Head of DevOps &amp; Analytics</a:t>
-            </a:r>
+              <a:t>Cyncly</a:t>
+            </a:r>
+            <a:r>
+              <a:rPr sz="750" b="0" i="0" dirty="0">
+                <a:solidFill>
+                  <a:srgbClr val="7386A0"/>
+                </a:solidFill>
+                <a:latin typeface="Segoe UI"/>
+              </a:rPr>
+              <a:t>  ·  </a:t>
+            </a:r>
+            <a:r>
+              <a:rPr lang="en-IN" sz="750" b="0" i="0" dirty="0">
+                <a:solidFill>
+                  <a:srgbClr val="7386A0"/>
+                </a:solidFill>
+                <a:latin typeface="Segoe UI"/>
+              </a:rPr>
+              <a:t>Head of DevOps</a:t>
+            </a:r>
+            <a:endParaRPr sz="750" b="0" i="0" dirty="0">
+              <a:solidFill>
+                <a:srgbClr val="7386A0"/>
+              </a:solidFill>
+              <a:latin typeface="Segoe UI"/>
+            </a:endParaRPr>
           </a:p>
         </p:txBody>
       </p:sp>
@@ -30396,7 +30548,7 @@
         <p:spPr>
           <a:xfrm>
             <a:off x="566928" y="6492240"/>
-            <a:ext cx="4023360" cy="182880"/>
+            <a:ext cx="4023360" cy="115416"/>
           </a:xfrm>
           <a:prstGeom prst="rect">
             <a:avLst/>
@@ -30421,14 +30573,38 @@
               </a:spcAft>
             </a:pPr>
             <a:r>
-              <a:rPr sz="750" b="0" i="0">
+              <a:rPr sz="750" b="0" i="0" dirty="0" err="1">
                 <a:solidFill>
                   <a:srgbClr val="7386A0"/>
                 </a:solidFill>
                 <a:latin typeface="Segoe UI"/>
               </a:rPr>
-              <a:t>Cyncly  ·  Head of DevOps &amp; Analytics</a:t>
-            </a:r>
+              <a:t>Cyncly</a:t>
+            </a:r>
+            <a:r>
+              <a:rPr sz="750" b="0" i="0" dirty="0">
+                <a:solidFill>
+                  <a:srgbClr val="7386A0"/>
+                </a:solidFill>
+                <a:latin typeface="Segoe UI"/>
+              </a:rPr>
+              <a:t>  ·  </a:t>
+            </a:r>
+            <a:r>
+              <a:rPr lang="en-IN" sz="750" b="0" i="0" dirty="0">
+                <a:solidFill>
+                  <a:srgbClr val="7386A0"/>
+                </a:solidFill>
+                <a:latin typeface="Segoe UI"/>
+              </a:rPr>
+              <a:t>Head of DevOps</a:t>
+            </a:r>
+            <a:endParaRPr sz="750" b="0" i="0" dirty="0">
+              <a:solidFill>
+                <a:srgbClr val="7386A0"/>
+              </a:solidFill>
+              <a:latin typeface="Segoe UI"/>
+            </a:endParaRPr>
           </a:p>
         </p:txBody>
       </p:sp>
@@ -33973,7 +34149,7 @@
         <p:spPr>
           <a:xfrm>
             <a:off x="566928" y="6492240"/>
-            <a:ext cx="4023360" cy="182880"/>
+            <a:ext cx="4023360" cy="115416"/>
           </a:xfrm>
           <a:prstGeom prst="rect">
             <a:avLst/>
@@ -33998,14 +34174,38 @@
               </a:spcAft>
             </a:pPr>
             <a:r>
-              <a:rPr sz="750" b="0" i="0">
+              <a:rPr sz="750" b="0" i="0" dirty="0" err="1">
                 <a:solidFill>
                   <a:srgbClr val="7386A0"/>
                 </a:solidFill>
                 <a:latin typeface="Segoe UI"/>
               </a:rPr>
-              <a:t>Cyncly  ·  Head of DevOps &amp; Analytics</a:t>
-            </a:r>
+              <a:t>Cyncly</a:t>
+            </a:r>
+            <a:r>
+              <a:rPr sz="750" b="0" i="0" dirty="0">
+                <a:solidFill>
+                  <a:srgbClr val="7386A0"/>
+                </a:solidFill>
+                <a:latin typeface="Segoe UI"/>
+              </a:rPr>
+              <a:t>  ·  </a:t>
+            </a:r>
+            <a:r>
+              <a:rPr lang="en-IN" sz="750" b="0" i="0" dirty="0">
+                <a:solidFill>
+                  <a:srgbClr val="7386A0"/>
+                </a:solidFill>
+                <a:latin typeface="Segoe UI"/>
+              </a:rPr>
+              <a:t>Head of DevOps</a:t>
+            </a:r>
+            <a:endParaRPr sz="750" b="0" i="0" dirty="0">
+              <a:solidFill>
+                <a:srgbClr val="7386A0"/>
+              </a:solidFill>
+              <a:latin typeface="Segoe UI"/>
+            </a:endParaRPr>
           </a:p>
         </p:txBody>
       </p:sp>
@@ -37043,7 +37243,7 @@
         <p:spPr>
           <a:xfrm>
             <a:off x="566928" y="6492240"/>
-            <a:ext cx="4023360" cy="182880"/>
+            <a:ext cx="4023360" cy="115416"/>
           </a:xfrm>
           <a:prstGeom prst="rect">
             <a:avLst/>
@@ -37068,13 +37268,22 @@
               </a:spcAft>
             </a:pPr>
             <a:r>
-              <a:rPr sz="750" b="0" i="0">
+              <a:rPr sz="750" b="0" i="0" dirty="0" err="1">
                 <a:solidFill>
                   <a:srgbClr val="7386A0"/>
                 </a:solidFill>
                 <a:latin typeface="Segoe UI"/>
               </a:rPr>
-              <a:t>Cyncly  ·  Head of DevOps &amp; Analytics</a:t>
+              <a:t>Cyncly</a:t>
+            </a:r>
+            <a:r>
+              <a:rPr sz="750" b="0" i="0" dirty="0">
+                <a:solidFill>
+                  <a:srgbClr val="7386A0"/>
+                </a:solidFill>
+                <a:latin typeface="Segoe UI"/>
+              </a:rPr>
+              <a:t>  ·  Head of DevOps </a:t>
             </a:r>
           </a:p>
         </p:txBody>

</xml_diff>